<commit_message>
chore(deck): actualiza PPTs del equipo Duqm (ES/EN) tras reestructura del organigrama
Co-Authored-By: Claude Fable 5 <noreply@anthropic.com>
</commit_message>
<xml_diff>
--- a/web/og-b0d2f7a3-files/Sigma-Digital-Twins-Equipo-Duqm-ES.pptx
+++ b/web/og-b0d2f7a3-files/Sigma-Digital-Twins-Equipo-Duqm-ES.pptx
@@ -15,7 +15,6 @@
     <p:sldId id="263" r:id="rId14"/>
     <p:sldId id="264" r:id="rId15"/>
     <p:sldId id="265" r:id="rId16"/>
-    <p:sldId id="266" r:id="rId17"/>
   </p:sldIdLst>
   <p:sldSz cx="12191695" cy="6858000" type="screen4x3"/>
   <p:notesSz cx="6858000" cy="9144000"/>
@@ -3098,40 +3097,104 @@
         <p:nvPr/>
       </p:nvGrpSpPr>
       <p:grpSpPr/>
-      <p:pic>
-        <p:nvPicPr>
-          <p:cNvPr id="2" name="Picture 1" descr="logo.png"/>
-          <p:cNvPicPr>
-            <a:picLocks noChangeAspect="1"/>
-          </p:cNvPicPr>
+      <p:sp>
+        <p:nvSpPr>
+          <p:cNvPr id="2" name="Rectangle 1"/>
+          <p:cNvSpPr/>
           <p:nvPr/>
-        </p:nvPicPr>
-        <p:blipFill>
-          <a:blip r:embed="rId2"/>
-          <a:stretch>
-            <a:fillRect/>
-          </a:stretch>
-        </p:blipFill>
-        <p:spPr>
-          <a:xfrm>
-            <a:off x="10789920" y="246888"/>
-            <a:ext cx="1161288" cy="1161288"/>
+        </p:nvSpPr>
+        <p:spPr>
+          <a:xfrm>
+            <a:off x="0" y="0"/>
+            <a:ext cx="12191695" cy="6858000"/>
           </a:xfrm>
           <a:prstGeom prst="rect">
             <a:avLst/>
           </a:prstGeom>
-        </p:spPr>
-      </p:pic>
-      <p:sp>
-        <p:nvSpPr>
-          <p:cNvPr id="3" name="TextBox 2"/>
+          <a:solidFill>
+            <a:srgbClr val="0B3D91"/>
+          </a:solidFill>
+          <a:ln>
+            <a:noFill/>
+          </a:ln>
+          <a:effectLst/>
+        </p:spPr>
+        <p:style>
+          <a:lnRef idx="1">
+            <a:schemeClr val="accent1"/>
+          </a:lnRef>
+          <a:fillRef idx="3">
+            <a:schemeClr val="accent1"/>
+          </a:fillRef>
+          <a:effectRef idx="2">
+            <a:schemeClr val="accent1"/>
+          </a:effectRef>
+          <a:fontRef idx="minor">
+            <a:schemeClr val="lt1"/>
+          </a:fontRef>
+        </p:style>
+        <p:txBody>
+          <a:bodyPr rtlCol="0" anchor="ctr"/>
+          <a:lstStyle/>
+          <a:p>
+            <a:pPr algn="ctr"/>
+          </a:p>
+        </p:txBody>
+      </p:sp>
+      <p:sp>
+        <p:nvSpPr>
+          <p:cNvPr id="3" name="Rectangle 2"/>
+          <p:cNvSpPr/>
+          <p:nvPr/>
+        </p:nvSpPr>
+        <p:spPr>
+          <a:xfrm>
+            <a:off x="0" y="4480560"/>
+            <a:ext cx="12191695" cy="38100"/>
+          </a:xfrm>
+          <a:prstGeom prst="rect">
+            <a:avLst/>
+          </a:prstGeom>
+          <a:solidFill>
+            <a:srgbClr val="1F6FEB"/>
+          </a:solidFill>
+          <a:ln>
+            <a:noFill/>
+          </a:ln>
+          <a:effectLst/>
+        </p:spPr>
+        <p:style>
+          <a:lnRef idx="1">
+            <a:schemeClr val="accent1"/>
+          </a:lnRef>
+          <a:fillRef idx="3">
+            <a:schemeClr val="accent1"/>
+          </a:fillRef>
+          <a:effectRef idx="2">
+            <a:schemeClr val="accent1"/>
+          </a:effectRef>
+          <a:fontRef idx="minor">
+            <a:schemeClr val="lt1"/>
+          </a:fontRef>
+        </p:style>
+        <p:txBody>
+          <a:bodyPr rtlCol="0" anchor="ctr"/>
+          <a:lstStyle/>
+          <a:p>
+            <a:pPr algn="ctr"/>
+          </a:p>
+        </p:txBody>
+      </p:sp>
+      <p:sp>
+        <p:nvSpPr>
+          <p:cNvPr id="4" name="TextBox 3"/>
           <p:cNvSpPr txBox="1"/>
           <p:nvPr/>
         </p:nvSpPr>
         <p:spPr>
           <a:xfrm>
-            <a:off x="301752" y="502920"/>
-            <a:ext cx="10241280" cy="365760"/>
+            <a:off x="822960" y="2011680"/>
+            <a:ext cx="10515600" cy="2377440"/>
           </a:xfrm>
           <a:prstGeom prst="rect">
             <a:avLst/>
@@ -3146,31 +3209,79 @@
           <a:p>
             <a:pPr>
               <a:spcAft>
-                <a:spcPts val="200"/>
-              </a:spcAft>
-            </a:pPr>
-            <a:r>
-              <a:rPr sz="1400" b="1">
-                <a:solidFill>
-                  <a:srgbClr val="1F6FEB"/>
+                <a:spcPts val="1000"/>
+              </a:spcAft>
+            </a:pPr>
+            <a:r>
+              <a:rPr sz="2000" b="1">
+                <a:solidFill>
+                  <a:srgbClr val="9FC1FF"/>
                 </a:solidFill>
                 <a:latin typeface="Calibri"/>
               </a:rPr>
               <a:t>SIGMA DIGITAL TWINS</a:t>
             </a:r>
           </a:p>
-        </p:txBody>
-      </p:sp>
-      <p:sp>
-        <p:nvSpPr>
-          <p:cNvPr id="4" name="TextBox 3"/>
+          <a:p>
+            <a:pPr>
+              <a:spcAft>
+                <a:spcPts val="800"/>
+              </a:spcAft>
+            </a:pPr>
+            <a:r>
+              <a:rPr sz="4400" b="1">
+                <a:solidFill>
+                  <a:srgbClr val="FFFFFF"/>
+                </a:solidFill>
+                <a:latin typeface="Calibri"/>
+              </a:rPr>
+              <a:t>Equipo Propuesto</a:t>
+            </a:r>
+          </a:p>
+          <a:p>
+            <a:pPr>
+              <a:spcAft>
+                <a:spcPts val="400"/>
+              </a:spcAft>
+            </a:pPr>
+            <a:r>
+              <a:rPr sz="2200" b="0">
+                <a:solidFill>
+                  <a:srgbClr val="FFFFFF"/>
+                </a:solidFill>
+                <a:latin typeface="Calibri"/>
+              </a:rPr>
+              <a:t>Proyecto de Recuperación de Minerales — Duqm, Omán</a:t>
+            </a:r>
+          </a:p>
+          <a:p>
+            <a:pPr>
+              <a:spcAft>
+                <a:spcPts val="200"/>
+              </a:spcAft>
+            </a:pPr>
+            <a:r>
+              <a:rPr sz="1400" b="0">
+                <a:solidFill>
+                  <a:srgbClr val="C8D8F5"/>
+                </a:solidFill>
+                <a:latin typeface="Calibri"/>
+              </a:rPr>
+              <a:t>Estudio Conceptual + Ingeniería Básica · Julio 2026</a:t>
+            </a:r>
+          </a:p>
+        </p:txBody>
+      </p:sp>
+      <p:sp>
+        <p:nvSpPr>
+          <p:cNvPr id="5" name="TextBox 4"/>
           <p:cNvSpPr txBox="1"/>
           <p:nvPr/>
         </p:nvSpPr>
         <p:spPr>
           <a:xfrm>
-            <a:off x="274320" y="1051560"/>
-            <a:ext cx="10332720" cy="960120"/>
+            <a:off x="822960" y="6035040"/>
+            <a:ext cx="10515600" cy="457200"/>
           </a:xfrm>
           <a:prstGeom prst="rect">
             <a:avLst/>
@@ -3189,111 +3300,9 @@
               </a:spcAft>
             </a:pPr>
             <a:r>
-              <a:rPr sz="3200" b="1">
-                <a:solidFill>
-                  <a:srgbClr val="141B26"/>
-                </a:solidFill>
-                <a:latin typeface="Calibri"/>
-              </a:rPr>
-              <a:t>Equipo Propuesto — Duqm, Omán</a:t>
-            </a:r>
-          </a:p>
-        </p:txBody>
-      </p:sp>
-      <p:sp>
-        <p:nvSpPr>
-          <p:cNvPr id="5" name="TextBox 4"/>
-          <p:cNvSpPr txBox="1"/>
-          <p:nvPr/>
-        </p:nvSpPr>
-        <p:spPr>
-          <a:xfrm>
-            <a:off x="301752" y="2057400"/>
-            <a:ext cx="10241280" cy="457200"/>
-          </a:xfrm>
-          <a:prstGeom prst="rect">
-            <a:avLst/>
-          </a:prstGeom>
-          <a:noFill/>
-        </p:spPr>
-        <p:txBody>
-          <a:bodyPr wrap="square">
-            <a:spAutoFit/>
-          </a:bodyPr>
-          <a:lstStyle/>
-          <a:p>
-            <a:pPr>
-              <a:spcAft>
-                <a:spcPts val="200"/>
-              </a:spcAft>
-            </a:pPr>
-            <a:r>
-              <a:rPr sz="1500" b="0">
-                <a:solidFill>
-                  <a:srgbClr val="5B6676"/>
-                </a:solidFill>
-                <a:latin typeface="Calibri"/>
-              </a:rPr>
-              <a:t>Proyecto de Recuperación de Minerales · Estudio Conceptual + Ingeniería Básica · Julio 2026</a:t>
-            </a:r>
-          </a:p>
-        </p:txBody>
-      </p:sp>
-      <p:pic>
-        <p:nvPicPr>
-          <p:cNvPr id="6" name="Picture 5" descr="cover_bg.jpg"/>
-          <p:cNvPicPr>
-            <a:picLocks noChangeAspect="1"/>
-          </p:cNvPicPr>
-          <p:nvPr/>
-        </p:nvPicPr>
-        <p:blipFill>
-          <a:blip r:embed="rId3"/>
-          <a:stretch>
-            <a:fillRect/>
-          </a:stretch>
-        </p:blipFill>
-        <p:spPr>
-          <a:xfrm>
-            <a:off x="301752" y="2834640"/>
-            <a:ext cx="11585448" cy="3291840"/>
-          </a:xfrm>
-          <a:prstGeom prst="rect">
-            <a:avLst/>
-          </a:prstGeom>
-        </p:spPr>
-      </p:pic>
-      <p:sp>
-        <p:nvSpPr>
-          <p:cNvPr id="7" name="TextBox 6"/>
-          <p:cNvSpPr txBox="1"/>
-          <p:nvPr/>
-        </p:nvSpPr>
-        <p:spPr>
-          <a:xfrm>
-            <a:off x="301752" y="6309360"/>
-            <a:ext cx="10515600" cy="365760"/>
-          </a:xfrm>
-          <a:prstGeom prst="rect">
-            <a:avLst/>
-          </a:prstGeom>
-          <a:noFill/>
-        </p:spPr>
-        <p:txBody>
-          <a:bodyPr wrap="square">
-            <a:spAutoFit/>
-          </a:bodyPr>
-          <a:lstStyle/>
-          <a:p>
-            <a:pPr>
-              <a:spcAft>
-                <a:spcPts val="200"/>
-              </a:spcAft>
-            </a:pPr>
-            <a:r>
               <a:rPr sz="1100" b="0">
                 <a:solidFill>
-                  <a:srgbClr val="5B6676"/>
+                  <a:srgbClr val="C8D8F5"/>
                 </a:solidFill>
                 <a:latin typeface="Calibri"/>
               </a:rPr>
@@ -3466,126 +3475,6 @@
                 <a:latin typeface="Calibri"/>
               </a:rPr>
               <a:t>Contacto: Jorge Juri — Project Manager · WhatsApp +1 778 835 3720</a:t>
-            </a:r>
-          </a:p>
-        </p:txBody>
-      </p:sp>
-    </p:spTree>
-  </p:cSld>
-  <p:clrMapOvr>
-    <a:masterClrMapping/>
-  </p:clrMapOvr>
-</p:sld>
-</file>
-
-<file path=ppt/slides/slide11.xml><?xml version="1.0" encoding="utf-8"?>
-<p:sld xmlns:a="http://schemas.openxmlformats.org/drawingml/2006/main" xmlns:p="http://schemas.openxmlformats.org/presentationml/2006/main" xmlns:r="http://schemas.openxmlformats.org/officeDocument/2006/relationships">
-  <p:cSld>
-    <p:spTree>
-      <p:nvGrpSpPr>
-        <p:cNvPr id="1" name=""/>
-        <p:cNvGrpSpPr/>
-        <p:nvPr/>
-      </p:nvGrpSpPr>
-      <p:grpSpPr/>
-      <p:sp>
-        <p:nvSpPr>
-          <p:cNvPr id="2" name="TextBox 1"/>
-          <p:cNvSpPr txBox="1"/>
-          <p:nvPr/>
-        </p:nvSpPr>
-        <p:spPr>
-          <a:xfrm>
-            <a:off x="155448" y="201168"/>
-            <a:ext cx="11795760" cy="676656"/>
-          </a:xfrm>
-          <a:prstGeom prst="rect">
-            <a:avLst/>
-          </a:prstGeom>
-          <a:noFill/>
-        </p:spPr>
-        <p:txBody>
-          <a:bodyPr wrap="square">
-            <a:spAutoFit/>
-          </a:bodyPr>
-          <a:lstStyle/>
-          <a:p>
-            <a:pPr>
-              <a:spcAft>
-                <a:spcPts val="200"/>
-              </a:spcAft>
-            </a:pPr>
-            <a:r>
-              <a:rPr sz="2400" b="1">
-                <a:solidFill>
-                  <a:srgbClr val="141B26"/>
-                </a:solidFill>
-                <a:latin typeface="Calibri"/>
-              </a:rPr>
-              <a:t>Acompáñanos en este viaje de innovación y transformación digital para tu negocio</a:t>
-            </a:r>
-          </a:p>
-        </p:txBody>
-      </p:sp>
-      <p:pic>
-        <p:nvPicPr>
-          <p:cNvPr id="3" name="Picture 2" descr="journey.jpg"/>
-          <p:cNvPicPr>
-            <a:picLocks noChangeAspect="1"/>
-          </p:cNvPicPr>
-          <p:nvPr/>
-        </p:nvPicPr>
-        <p:blipFill>
-          <a:blip r:embed="rId2"/>
-          <a:stretch>
-            <a:fillRect/>
-          </a:stretch>
-        </p:blipFill>
-        <p:spPr>
-          <a:xfrm>
-            <a:off x="0" y="822960"/>
-            <a:ext cx="12191695" cy="5148072"/>
-          </a:xfrm>
-          <a:prstGeom prst="rect">
-            <a:avLst/>
-          </a:prstGeom>
-        </p:spPr>
-      </p:pic>
-      <p:sp>
-        <p:nvSpPr>
-          <p:cNvPr id="4" name="TextBox 3"/>
-          <p:cNvSpPr txBox="1"/>
-          <p:nvPr/>
-        </p:nvSpPr>
-        <p:spPr>
-          <a:xfrm>
-            <a:off x="301752" y="6144768"/>
-            <a:ext cx="10972800" cy="457200"/>
-          </a:xfrm>
-          <a:prstGeom prst="rect">
-            <a:avLst/>
-          </a:prstGeom>
-          <a:noFill/>
-        </p:spPr>
-        <p:txBody>
-          <a:bodyPr wrap="square">
-            <a:spAutoFit/>
-          </a:bodyPr>
-          <a:lstStyle/>
-          <a:p>
-            <a:pPr>
-              <a:spcAft>
-                <a:spcPts val="200"/>
-              </a:spcAft>
-            </a:pPr>
-            <a:r>
-              <a:rPr sz="1200" b="0">
-                <a:solidFill>
-                  <a:srgbClr val="5B6676"/>
-                </a:solidFill>
-                <a:latin typeface="Calibri"/>
-              </a:rPr>
-              <a:t>Contacto: Jorge Juri — Project Manager · WhatsApp +1 778 835 3720 · Sigma Digital Twins</a:t>
             </a:r>
           </a:p>
         </p:txBody>

</xml_diff>

<commit_message>
fix(oman): restaura PPT v2 (Casos de Éxito, org 3 ramas, aporte al proyecto) pisada por regeneración con script v1
Co-Authored-By: Claude Fable 5 <noreply@anthropic.com>
</commit_message>
<xml_diff>
--- a/web/og-b0d2f7a3-files/Sigma-Digital-Twins-Equipo-Duqm-ES.pptx
+++ b/web/og-b0d2f7a3-files/Sigma-Digital-Twins-Equipo-Duqm-ES.pptx
@@ -15,6 +15,7 @@
     <p:sldId id="263" r:id="rId14"/>
     <p:sldId id="264" r:id="rId15"/>
     <p:sldId id="265" r:id="rId16"/>
+    <p:sldId id="266" r:id="rId17"/>
   </p:sldIdLst>
   <p:sldSz cx="12191695" cy="6858000" type="screen4x3"/>
   <p:notesSz cx="6858000" cy="9144000"/>
@@ -3097,104 +3098,40 @@
         <p:nvPr/>
       </p:nvGrpSpPr>
       <p:grpSpPr/>
-      <p:sp>
-        <p:nvSpPr>
-          <p:cNvPr id="2" name="Rectangle 1"/>
-          <p:cNvSpPr/>
-          <p:nvPr/>
-        </p:nvSpPr>
-        <p:spPr>
-          <a:xfrm>
-            <a:off x="0" y="0"/>
-            <a:ext cx="12191695" cy="6858000"/>
+      <p:pic>
+        <p:nvPicPr>
+          <p:cNvPr id="2" name="Picture 1" descr="logo.png"/>
+          <p:cNvPicPr>
+            <a:picLocks noChangeAspect="1"/>
+          </p:cNvPicPr>
+          <p:nvPr/>
+        </p:nvPicPr>
+        <p:blipFill>
+          <a:blip r:embed="rId2"/>
+          <a:stretch>
+            <a:fillRect/>
+          </a:stretch>
+        </p:blipFill>
+        <p:spPr>
+          <a:xfrm>
+            <a:off x="10789920" y="246888"/>
+            <a:ext cx="1161288" cy="1161288"/>
           </a:xfrm>
           <a:prstGeom prst="rect">
             <a:avLst/>
           </a:prstGeom>
-          <a:solidFill>
-            <a:srgbClr val="0B3D91"/>
-          </a:solidFill>
-          <a:ln>
-            <a:noFill/>
-          </a:ln>
-          <a:effectLst/>
-        </p:spPr>
-        <p:style>
-          <a:lnRef idx="1">
-            <a:schemeClr val="accent1"/>
-          </a:lnRef>
-          <a:fillRef idx="3">
-            <a:schemeClr val="accent1"/>
-          </a:fillRef>
-          <a:effectRef idx="2">
-            <a:schemeClr val="accent1"/>
-          </a:effectRef>
-          <a:fontRef idx="minor">
-            <a:schemeClr val="lt1"/>
-          </a:fontRef>
-        </p:style>
-        <p:txBody>
-          <a:bodyPr rtlCol="0" anchor="ctr"/>
-          <a:lstStyle/>
-          <a:p>
-            <a:pPr algn="ctr"/>
-          </a:p>
-        </p:txBody>
-      </p:sp>
-      <p:sp>
-        <p:nvSpPr>
-          <p:cNvPr id="3" name="Rectangle 2"/>
-          <p:cNvSpPr/>
-          <p:nvPr/>
-        </p:nvSpPr>
-        <p:spPr>
-          <a:xfrm>
-            <a:off x="0" y="4480560"/>
-            <a:ext cx="12191695" cy="38100"/>
-          </a:xfrm>
-          <a:prstGeom prst="rect">
-            <a:avLst/>
-          </a:prstGeom>
-          <a:solidFill>
-            <a:srgbClr val="1F6FEB"/>
-          </a:solidFill>
-          <a:ln>
-            <a:noFill/>
-          </a:ln>
-          <a:effectLst/>
-        </p:spPr>
-        <p:style>
-          <a:lnRef idx="1">
-            <a:schemeClr val="accent1"/>
-          </a:lnRef>
-          <a:fillRef idx="3">
-            <a:schemeClr val="accent1"/>
-          </a:fillRef>
-          <a:effectRef idx="2">
-            <a:schemeClr val="accent1"/>
-          </a:effectRef>
-          <a:fontRef idx="minor">
-            <a:schemeClr val="lt1"/>
-          </a:fontRef>
-        </p:style>
-        <p:txBody>
-          <a:bodyPr rtlCol="0" anchor="ctr"/>
-          <a:lstStyle/>
-          <a:p>
-            <a:pPr algn="ctr"/>
-          </a:p>
-        </p:txBody>
-      </p:sp>
-      <p:sp>
-        <p:nvSpPr>
-          <p:cNvPr id="4" name="TextBox 3"/>
+        </p:spPr>
+      </p:pic>
+      <p:sp>
+        <p:nvSpPr>
+          <p:cNvPr id="3" name="TextBox 2"/>
           <p:cNvSpPr txBox="1"/>
           <p:nvPr/>
         </p:nvSpPr>
         <p:spPr>
           <a:xfrm>
-            <a:off x="822960" y="2011680"/>
-            <a:ext cx="10515600" cy="2377440"/>
+            <a:off x="301752" y="502920"/>
+            <a:ext cx="10241280" cy="365760"/>
           </a:xfrm>
           <a:prstGeom prst="rect">
             <a:avLst/>
@@ -3209,79 +3146,31 @@
           <a:p>
             <a:pPr>
               <a:spcAft>
-                <a:spcPts val="1000"/>
-              </a:spcAft>
-            </a:pPr>
-            <a:r>
-              <a:rPr sz="2000" b="1">
-                <a:solidFill>
-                  <a:srgbClr val="9FC1FF"/>
+                <a:spcPts val="200"/>
+              </a:spcAft>
+            </a:pPr>
+            <a:r>
+              <a:rPr sz="1400" b="1">
+                <a:solidFill>
+                  <a:srgbClr val="1F6FEB"/>
                 </a:solidFill>
                 <a:latin typeface="Calibri"/>
               </a:rPr>
               <a:t>SIGMA DIGITAL TWINS</a:t>
             </a:r>
           </a:p>
-          <a:p>
-            <a:pPr>
-              <a:spcAft>
-                <a:spcPts val="800"/>
-              </a:spcAft>
-            </a:pPr>
-            <a:r>
-              <a:rPr sz="4400" b="1">
-                <a:solidFill>
-                  <a:srgbClr val="FFFFFF"/>
-                </a:solidFill>
-                <a:latin typeface="Calibri"/>
-              </a:rPr>
-              <a:t>Equipo Propuesto</a:t>
-            </a:r>
-          </a:p>
-          <a:p>
-            <a:pPr>
-              <a:spcAft>
-                <a:spcPts val="400"/>
-              </a:spcAft>
-            </a:pPr>
-            <a:r>
-              <a:rPr sz="2200" b="0">
-                <a:solidFill>
-                  <a:srgbClr val="FFFFFF"/>
-                </a:solidFill>
-                <a:latin typeface="Calibri"/>
-              </a:rPr>
-              <a:t>Proyecto de Recuperación de Minerales — Duqm, Omán</a:t>
-            </a:r>
-          </a:p>
-          <a:p>
-            <a:pPr>
-              <a:spcAft>
-                <a:spcPts val="200"/>
-              </a:spcAft>
-            </a:pPr>
-            <a:r>
-              <a:rPr sz="1400" b="0">
-                <a:solidFill>
-                  <a:srgbClr val="C8D8F5"/>
-                </a:solidFill>
-                <a:latin typeface="Calibri"/>
-              </a:rPr>
-              <a:t>Estudio Conceptual + Ingeniería Básica · Julio 2026</a:t>
-            </a:r>
-          </a:p>
-        </p:txBody>
-      </p:sp>
-      <p:sp>
-        <p:nvSpPr>
-          <p:cNvPr id="5" name="TextBox 4"/>
+        </p:txBody>
+      </p:sp>
+      <p:sp>
+        <p:nvSpPr>
+          <p:cNvPr id="4" name="TextBox 3"/>
           <p:cNvSpPr txBox="1"/>
           <p:nvPr/>
         </p:nvSpPr>
         <p:spPr>
           <a:xfrm>
-            <a:off x="822960" y="6035040"/>
-            <a:ext cx="10515600" cy="457200"/>
+            <a:off x="274320" y="1051560"/>
+            <a:ext cx="10332720" cy="960120"/>
           </a:xfrm>
           <a:prstGeom prst="rect">
             <a:avLst/>
@@ -3300,9 +3189,111 @@
               </a:spcAft>
             </a:pPr>
             <a:r>
+              <a:rPr sz="3200" b="1">
+                <a:solidFill>
+                  <a:srgbClr val="141B26"/>
+                </a:solidFill>
+                <a:latin typeface="Calibri"/>
+              </a:rPr>
+              <a:t>Equipo Propuesto — Duqm, Omán</a:t>
+            </a:r>
+          </a:p>
+        </p:txBody>
+      </p:sp>
+      <p:sp>
+        <p:nvSpPr>
+          <p:cNvPr id="5" name="TextBox 4"/>
+          <p:cNvSpPr txBox="1"/>
+          <p:nvPr/>
+        </p:nvSpPr>
+        <p:spPr>
+          <a:xfrm>
+            <a:off x="301752" y="2057400"/>
+            <a:ext cx="10241280" cy="457200"/>
+          </a:xfrm>
+          <a:prstGeom prst="rect">
+            <a:avLst/>
+          </a:prstGeom>
+          <a:noFill/>
+        </p:spPr>
+        <p:txBody>
+          <a:bodyPr wrap="square">
+            <a:spAutoFit/>
+          </a:bodyPr>
+          <a:lstStyle/>
+          <a:p>
+            <a:pPr>
+              <a:spcAft>
+                <a:spcPts val="200"/>
+              </a:spcAft>
+            </a:pPr>
+            <a:r>
+              <a:rPr sz="1500" b="0">
+                <a:solidFill>
+                  <a:srgbClr val="5B6676"/>
+                </a:solidFill>
+                <a:latin typeface="Calibri"/>
+              </a:rPr>
+              <a:t>Proyecto de Recuperación de Minerales · Estudio Conceptual + Ingeniería Básica · Julio 2026</a:t>
+            </a:r>
+          </a:p>
+        </p:txBody>
+      </p:sp>
+      <p:pic>
+        <p:nvPicPr>
+          <p:cNvPr id="6" name="Picture 5" descr="cover_bg.jpg"/>
+          <p:cNvPicPr>
+            <a:picLocks noChangeAspect="1"/>
+          </p:cNvPicPr>
+          <p:nvPr/>
+        </p:nvPicPr>
+        <p:blipFill>
+          <a:blip r:embed="rId3"/>
+          <a:stretch>
+            <a:fillRect/>
+          </a:stretch>
+        </p:blipFill>
+        <p:spPr>
+          <a:xfrm>
+            <a:off x="301752" y="2834640"/>
+            <a:ext cx="11585448" cy="3291840"/>
+          </a:xfrm>
+          <a:prstGeom prst="rect">
+            <a:avLst/>
+          </a:prstGeom>
+        </p:spPr>
+      </p:pic>
+      <p:sp>
+        <p:nvSpPr>
+          <p:cNvPr id="7" name="TextBox 6"/>
+          <p:cNvSpPr txBox="1"/>
+          <p:nvPr/>
+        </p:nvSpPr>
+        <p:spPr>
+          <a:xfrm>
+            <a:off x="301752" y="6309360"/>
+            <a:ext cx="10515600" cy="365760"/>
+          </a:xfrm>
+          <a:prstGeom prst="rect">
+            <a:avLst/>
+          </a:prstGeom>
+          <a:noFill/>
+        </p:spPr>
+        <p:txBody>
+          <a:bodyPr wrap="square">
+            <a:spAutoFit/>
+          </a:bodyPr>
+          <a:lstStyle/>
+          <a:p>
+            <a:pPr>
+              <a:spcAft>
+                <a:spcPts val="200"/>
+              </a:spcAft>
+            </a:pPr>
+            <a:r>
               <a:rPr sz="1100" b="0">
                 <a:solidFill>
-                  <a:srgbClr val="C8D8F5"/>
+                  <a:srgbClr val="5B6676"/>
                 </a:solidFill>
                 <a:latin typeface="Calibri"/>
               </a:rPr>
@@ -3475,6 +3466,126 @@
                 <a:latin typeface="Calibri"/>
               </a:rPr>
               <a:t>Contacto: Jorge Juri — Project Manager · WhatsApp +1 778 835 3720</a:t>
+            </a:r>
+          </a:p>
+        </p:txBody>
+      </p:sp>
+    </p:spTree>
+  </p:cSld>
+  <p:clrMapOvr>
+    <a:masterClrMapping/>
+  </p:clrMapOvr>
+</p:sld>
+</file>
+
+<file path=ppt/slides/slide11.xml><?xml version="1.0" encoding="utf-8"?>
+<p:sld xmlns:a="http://schemas.openxmlformats.org/drawingml/2006/main" xmlns:p="http://schemas.openxmlformats.org/presentationml/2006/main" xmlns:r="http://schemas.openxmlformats.org/officeDocument/2006/relationships">
+  <p:cSld>
+    <p:spTree>
+      <p:nvGrpSpPr>
+        <p:cNvPr id="1" name=""/>
+        <p:cNvGrpSpPr/>
+        <p:nvPr/>
+      </p:nvGrpSpPr>
+      <p:grpSpPr/>
+      <p:sp>
+        <p:nvSpPr>
+          <p:cNvPr id="2" name="TextBox 1"/>
+          <p:cNvSpPr txBox="1"/>
+          <p:nvPr/>
+        </p:nvSpPr>
+        <p:spPr>
+          <a:xfrm>
+            <a:off x="155448" y="201168"/>
+            <a:ext cx="11795760" cy="676656"/>
+          </a:xfrm>
+          <a:prstGeom prst="rect">
+            <a:avLst/>
+          </a:prstGeom>
+          <a:noFill/>
+        </p:spPr>
+        <p:txBody>
+          <a:bodyPr wrap="square">
+            <a:spAutoFit/>
+          </a:bodyPr>
+          <a:lstStyle/>
+          <a:p>
+            <a:pPr>
+              <a:spcAft>
+                <a:spcPts val="200"/>
+              </a:spcAft>
+            </a:pPr>
+            <a:r>
+              <a:rPr sz="2400" b="1">
+                <a:solidFill>
+                  <a:srgbClr val="141B26"/>
+                </a:solidFill>
+                <a:latin typeface="Calibri"/>
+              </a:rPr>
+              <a:t>Acompáñanos en este viaje de innovación y transformación digital para tu negocio</a:t>
+            </a:r>
+          </a:p>
+        </p:txBody>
+      </p:sp>
+      <p:pic>
+        <p:nvPicPr>
+          <p:cNvPr id="3" name="Picture 2" descr="journey.jpg"/>
+          <p:cNvPicPr>
+            <a:picLocks noChangeAspect="1"/>
+          </p:cNvPicPr>
+          <p:nvPr/>
+        </p:nvPicPr>
+        <p:blipFill>
+          <a:blip r:embed="rId2"/>
+          <a:stretch>
+            <a:fillRect/>
+          </a:stretch>
+        </p:blipFill>
+        <p:spPr>
+          <a:xfrm>
+            <a:off x="0" y="822960"/>
+            <a:ext cx="12191695" cy="5148072"/>
+          </a:xfrm>
+          <a:prstGeom prst="rect">
+            <a:avLst/>
+          </a:prstGeom>
+        </p:spPr>
+      </p:pic>
+      <p:sp>
+        <p:nvSpPr>
+          <p:cNvPr id="4" name="TextBox 3"/>
+          <p:cNvSpPr txBox="1"/>
+          <p:nvPr/>
+        </p:nvSpPr>
+        <p:spPr>
+          <a:xfrm>
+            <a:off x="301752" y="6144768"/>
+            <a:ext cx="10972800" cy="457200"/>
+          </a:xfrm>
+          <a:prstGeom prst="rect">
+            <a:avLst/>
+          </a:prstGeom>
+          <a:noFill/>
+        </p:spPr>
+        <p:txBody>
+          <a:bodyPr wrap="square">
+            <a:spAutoFit/>
+          </a:bodyPr>
+          <a:lstStyle/>
+          <a:p>
+            <a:pPr>
+              <a:spcAft>
+                <a:spcPts val="200"/>
+              </a:spcAft>
+            </a:pPr>
+            <a:r>
+              <a:rPr sz="1200" b="0">
+                <a:solidFill>
+                  <a:srgbClr val="5B6676"/>
+                </a:solidFill>
+                <a:latin typeface="Calibri"/>
+              </a:rPr>
+              <a:t>Contacto: Jorge Juri — Project Manager · WhatsApp +1 778 835 3720 · Sigma Digital Twins</a:t>
             </a:r>
           </a:p>
         </p:txBody>

</xml_diff>

<commit_message>
fix(deck): coordenadas EMU enteras — elimina el 'Repair' de PowerPoint (floats en organigrama violaban ST_Coordinate)
Co-Authored-By: Claude Fable 5 <noreply@anthropic.com>
</commit_message>
<xml_diff>
--- a/web/og-b0d2f7a3-files/Sigma-Digital-Twins-Equipo-Duqm-ES.pptx
+++ b/web/og-b0d2f7a3-files/Sigma-Digital-Twins-Equipo-Duqm-ES.pptx
@@ -15,7 +15,6 @@
     <p:sldId id="263" r:id="rId14"/>
     <p:sldId id="264" r:id="rId15"/>
     <p:sldId id="265" r:id="rId16"/>
-    <p:sldId id="266" r:id="rId17"/>
   </p:sldIdLst>
   <p:sldSz cx="12191695" cy="6858000" type="screen4x3"/>
   <p:notesSz cx="6858000" cy="9144000"/>
@@ -3098,40 +3097,104 @@
         <p:nvPr/>
       </p:nvGrpSpPr>
       <p:grpSpPr/>
-      <p:pic>
-        <p:nvPicPr>
-          <p:cNvPr id="2" name="Picture 1" descr="logo.png"/>
-          <p:cNvPicPr>
-            <a:picLocks noChangeAspect="1"/>
-          </p:cNvPicPr>
+      <p:sp>
+        <p:nvSpPr>
+          <p:cNvPr id="2" name="Rectangle 1"/>
+          <p:cNvSpPr/>
           <p:nvPr/>
-        </p:nvPicPr>
-        <p:blipFill>
-          <a:blip r:embed="rId2"/>
-          <a:stretch>
-            <a:fillRect/>
-          </a:stretch>
-        </p:blipFill>
-        <p:spPr>
-          <a:xfrm>
-            <a:off x="10789920" y="246888"/>
-            <a:ext cx="1161288" cy="1161288"/>
+        </p:nvSpPr>
+        <p:spPr>
+          <a:xfrm>
+            <a:off x="0" y="0"/>
+            <a:ext cx="12191695" cy="6858000"/>
           </a:xfrm>
           <a:prstGeom prst="rect">
             <a:avLst/>
           </a:prstGeom>
-        </p:spPr>
-      </p:pic>
-      <p:sp>
-        <p:nvSpPr>
-          <p:cNvPr id="3" name="TextBox 2"/>
+          <a:solidFill>
+            <a:srgbClr val="0B3D91"/>
+          </a:solidFill>
+          <a:ln>
+            <a:noFill/>
+          </a:ln>
+          <a:effectLst/>
+        </p:spPr>
+        <p:style>
+          <a:lnRef idx="1">
+            <a:schemeClr val="accent1"/>
+          </a:lnRef>
+          <a:fillRef idx="3">
+            <a:schemeClr val="accent1"/>
+          </a:fillRef>
+          <a:effectRef idx="2">
+            <a:schemeClr val="accent1"/>
+          </a:effectRef>
+          <a:fontRef idx="minor">
+            <a:schemeClr val="lt1"/>
+          </a:fontRef>
+        </p:style>
+        <p:txBody>
+          <a:bodyPr rtlCol="0" anchor="ctr"/>
+          <a:lstStyle/>
+          <a:p>
+            <a:pPr algn="ctr"/>
+          </a:p>
+        </p:txBody>
+      </p:sp>
+      <p:sp>
+        <p:nvSpPr>
+          <p:cNvPr id="3" name="Rectangle 2"/>
+          <p:cNvSpPr/>
+          <p:nvPr/>
+        </p:nvSpPr>
+        <p:spPr>
+          <a:xfrm>
+            <a:off x="0" y="4480560"/>
+            <a:ext cx="12191695" cy="38100"/>
+          </a:xfrm>
+          <a:prstGeom prst="rect">
+            <a:avLst/>
+          </a:prstGeom>
+          <a:solidFill>
+            <a:srgbClr val="1F6FEB"/>
+          </a:solidFill>
+          <a:ln>
+            <a:noFill/>
+          </a:ln>
+          <a:effectLst/>
+        </p:spPr>
+        <p:style>
+          <a:lnRef idx="1">
+            <a:schemeClr val="accent1"/>
+          </a:lnRef>
+          <a:fillRef idx="3">
+            <a:schemeClr val="accent1"/>
+          </a:fillRef>
+          <a:effectRef idx="2">
+            <a:schemeClr val="accent1"/>
+          </a:effectRef>
+          <a:fontRef idx="minor">
+            <a:schemeClr val="lt1"/>
+          </a:fontRef>
+        </p:style>
+        <p:txBody>
+          <a:bodyPr rtlCol="0" anchor="ctr"/>
+          <a:lstStyle/>
+          <a:p>
+            <a:pPr algn="ctr"/>
+          </a:p>
+        </p:txBody>
+      </p:sp>
+      <p:sp>
+        <p:nvSpPr>
+          <p:cNvPr id="4" name="TextBox 3"/>
           <p:cNvSpPr txBox="1"/>
           <p:nvPr/>
         </p:nvSpPr>
         <p:spPr>
           <a:xfrm>
-            <a:off x="301752" y="502920"/>
-            <a:ext cx="10241280" cy="365760"/>
+            <a:off x="822960" y="2011680"/>
+            <a:ext cx="10515600" cy="2377440"/>
           </a:xfrm>
           <a:prstGeom prst="rect">
             <a:avLst/>
@@ -3146,31 +3209,79 @@
           <a:p>
             <a:pPr>
               <a:spcAft>
-                <a:spcPts val="200"/>
-              </a:spcAft>
-            </a:pPr>
-            <a:r>
-              <a:rPr sz="1400" b="1">
-                <a:solidFill>
-                  <a:srgbClr val="1F6FEB"/>
+                <a:spcPts val="1000"/>
+              </a:spcAft>
+            </a:pPr>
+            <a:r>
+              <a:rPr sz="2000" b="1">
+                <a:solidFill>
+                  <a:srgbClr val="9FC1FF"/>
                 </a:solidFill>
                 <a:latin typeface="Calibri"/>
               </a:rPr>
               <a:t>SIGMA DIGITAL TWINS</a:t>
             </a:r>
           </a:p>
-        </p:txBody>
-      </p:sp>
-      <p:sp>
-        <p:nvSpPr>
-          <p:cNvPr id="4" name="TextBox 3"/>
+          <a:p>
+            <a:pPr>
+              <a:spcAft>
+                <a:spcPts val="800"/>
+              </a:spcAft>
+            </a:pPr>
+            <a:r>
+              <a:rPr sz="4400" b="1">
+                <a:solidFill>
+                  <a:srgbClr val="FFFFFF"/>
+                </a:solidFill>
+                <a:latin typeface="Calibri"/>
+              </a:rPr>
+              <a:t>Equipo Propuesto</a:t>
+            </a:r>
+          </a:p>
+          <a:p>
+            <a:pPr>
+              <a:spcAft>
+                <a:spcPts val="400"/>
+              </a:spcAft>
+            </a:pPr>
+            <a:r>
+              <a:rPr sz="2200" b="0">
+                <a:solidFill>
+                  <a:srgbClr val="FFFFFF"/>
+                </a:solidFill>
+                <a:latin typeface="Calibri"/>
+              </a:rPr>
+              <a:t>Proyecto de Recuperación de Minerales — Duqm, Omán</a:t>
+            </a:r>
+          </a:p>
+          <a:p>
+            <a:pPr>
+              <a:spcAft>
+                <a:spcPts val="200"/>
+              </a:spcAft>
+            </a:pPr>
+            <a:r>
+              <a:rPr sz="1400" b="0">
+                <a:solidFill>
+                  <a:srgbClr val="C8D8F5"/>
+                </a:solidFill>
+                <a:latin typeface="Calibri"/>
+              </a:rPr>
+              <a:t>Estudio Conceptual + Ingeniería Básica · Julio 2026</a:t>
+            </a:r>
+          </a:p>
+        </p:txBody>
+      </p:sp>
+      <p:sp>
+        <p:nvSpPr>
+          <p:cNvPr id="5" name="TextBox 4"/>
           <p:cNvSpPr txBox="1"/>
           <p:nvPr/>
         </p:nvSpPr>
         <p:spPr>
           <a:xfrm>
-            <a:off x="274320" y="1051560"/>
-            <a:ext cx="10332720" cy="960120"/>
+            <a:off x="822960" y="6035040"/>
+            <a:ext cx="10515600" cy="457200"/>
           </a:xfrm>
           <a:prstGeom prst="rect">
             <a:avLst/>
@@ -3189,111 +3300,9 @@
               </a:spcAft>
             </a:pPr>
             <a:r>
-              <a:rPr sz="3200" b="1">
-                <a:solidFill>
-                  <a:srgbClr val="141B26"/>
-                </a:solidFill>
-                <a:latin typeface="Calibri"/>
-              </a:rPr>
-              <a:t>Equipo Propuesto — Duqm, Omán</a:t>
-            </a:r>
-          </a:p>
-        </p:txBody>
-      </p:sp>
-      <p:sp>
-        <p:nvSpPr>
-          <p:cNvPr id="5" name="TextBox 4"/>
-          <p:cNvSpPr txBox="1"/>
-          <p:nvPr/>
-        </p:nvSpPr>
-        <p:spPr>
-          <a:xfrm>
-            <a:off x="301752" y="2057400"/>
-            <a:ext cx="10241280" cy="457200"/>
-          </a:xfrm>
-          <a:prstGeom prst="rect">
-            <a:avLst/>
-          </a:prstGeom>
-          <a:noFill/>
-        </p:spPr>
-        <p:txBody>
-          <a:bodyPr wrap="square">
-            <a:spAutoFit/>
-          </a:bodyPr>
-          <a:lstStyle/>
-          <a:p>
-            <a:pPr>
-              <a:spcAft>
-                <a:spcPts val="200"/>
-              </a:spcAft>
-            </a:pPr>
-            <a:r>
-              <a:rPr sz="1500" b="0">
-                <a:solidFill>
-                  <a:srgbClr val="5B6676"/>
-                </a:solidFill>
-                <a:latin typeface="Calibri"/>
-              </a:rPr>
-              <a:t>Proyecto de Recuperación de Minerales · Estudio Conceptual + Ingeniería Básica · Julio 2026</a:t>
-            </a:r>
-          </a:p>
-        </p:txBody>
-      </p:sp>
-      <p:pic>
-        <p:nvPicPr>
-          <p:cNvPr id="6" name="Picture 5" descr="cover_bg.jpg"/>
-          <p:cNvPicPr>
-            <a:picLocks noChangeAspect="1"/>
-          </p:cNvPicPr>
-          <p:nvPr/>
-        </p:nvPicPr>
-        <p:blipFill>
-          <a:blip r:embed="rId3"/>
-          <a:stretch>
-            <a:fillRect/>
-          </a:stretch>
-        </p:blipFill>
-        <p:spPr>
-          <a:xfrm>
-            <a:off x="301752" y="2834640"/>
-            <a:ext cx="11585448" cy="3291840"/>
-          </a:xfrm>
-          <a:prstGeom prst="rect">
-            <a:avLst/>
-          </a:prstGeom>
-        </p:spPr>
-      </p:pic>
-      <p:sp>
-        <p:nvSpPr>
-          <p:cNvPr id="7" name="TextBox 6"/>
-          <p:cNvSpPr txBox="1"/>
-          <p:nvPr/>
-        </p:nvSpPr>
-        <p:spPr>
-          <a:xfrm>
-            <a:off x="301752" y="6309360"/>
-            <a:ext cx="10515600" cy="365760"/>
-          </a:xfrm>
-          <a:prstGeom prst="rect">
-            <a:avLst/>
-          </a:prstGeom>
-          <a:noFill/>
-        </p:spPr>
-        <p:txBody>
-          <a:bodyPr wrap="square">
-            <a:spAutoFit/>
-          </a:bodyPr>
-          <a:lstStyle/>
-          <a:p>
-            <a:pPr>
-              <a:spcAft>
-                <a:spcPts val="200"/>
-              </a:spcAft>
-            </a:pPr>
-            <a:r>
               <a:rPr sz="1100" b="0">
                 <a:solidFill>
-                  <a:srgbClr val="5B6676"/>
+                  <a:srgbClr val="C8D8F5"/>
                 </a:solidFill>
                 <a:latin typeface="Calibri"/>
               </a:rPr>
@@ -3478,126 +3487,6 @@
 </p:sld>
 </file>
 
-<file path=ppt/slides/slide11.xml><?xml version="1.0" encoding="utf-8"?>
-<p:sld xmlns:a="http://schemas.openxmlformats.org/drawingml/2006/main" xmlns:p="http://schemas.openxmlformats.org/presentationml/2006/main" xmlns:r="http://schemas.openxmlformats.org/officeDocument/2006/relationships">
-  <p:cSld>
-    <p:spTree>
-      <p:nvGrpSpPr>
-        <p:cNvPr id="1" name=""/>
-        <p:cNvGrpSpPr/>
-        <p:nvPr/>
-      </p:nvGrpSpPr>
-      <p:grpSpPr/>
-      <p:sp>
-        <p:nvSpPr>
-          <p:cNvPr id="2" name="TextBox 1"/>
-          <p:cNvSpPr txBox="1"/>
-          <p:nvPr/>
-        </p:nvSpPr>
-        <p:spPr>
-          <a:xfrm>
-            <a:off x="155448" y="201168"/>
-            <a:ext cx="11795760" cy="676656"/>
-          </a:xfrm>
-          <a:prstGeom prst="rect">
-            <a:avLst/>
-          </a:prstGeom>
-          <a:noFill/>
-        </p:spPr>
-        <p:txBody>
-          <a:bodyPr wrap="square">
-            <a:spAutoFit/>
-          </a:bodyPr>
-          <a:lstStyle/>
-          <a:p>
-            <a:pPr>
-              <a:spcAft>
-                <a:spcPts val="200"/>
-              </a:spcAft>
-            </a:pPr>
-            <a:r>
-              <a:rPr sz="2400" b="1">
-                <a:solidFill>
-                  <a:srgbClr val="141B26"/>
-                </a:solidFill>
-                <a:latin typeface="Calibri"/>
-              </a:rPr>
-              <a:t>Acompáñanos en este viaje de innovación y transformación digital para tu negocio</a:t>
-            </a:r>
-          </a:p>
-        </p:txBody>
-      </p:sp>
-      <p:pic>
-        <p:nvPicPr>
-          <p:cNvPr id="3" name="Picture 2" descr="journey.jpg"/>
-          <p:cNvPicPr>
-            <a:picLocks noChangeAspect="1"/>
-          </p:cNvPicPr>
-          <p:nvPr/>
-        </p:nvPicPr>
-        <p:blipFill>
-          <a:blip r:embed="rId2"/>
-          <a:stretch>
-            <a:fillRect/>
-          </a:stretch>
-        </p:blipFill>
-        <p:spPr>
-          <a:xfrm>
-            <a:off x="0" y="822960"/>
-            <a:ext cx="12191695" cy="5148072"/>
-          </a:xfrm>
-          <a:prstGeom prst="rect">
-            <a:avLst/>
-          </a:prstGeom>
-        </p:spPr>
-      </p:pic>
-      <p:sp>
-        <p:nvSpPr>
-          <p:cNvPr id="4" name="TextBox 3"/>
-          <p:cNvSpPr txBox="1"/>
-          <p:nvPr/>
-        </p:nvSpPr>
-        <p:spPr>
-          <a:xfrm>
-            <a:off x="301752" y="6144768"/>
-            <a:ext cx="10972800" cy="457200"/>
-          </a:xfrm>
-          <a:prstGeom prst="rect">
-            <a:avLst/>
-          </a:prstGeom>
-          <a:noFill/>
-        </p:spPr>
-        <p:txBody>
-          <a:bodyPr wrap="square">
-            <a:spAutoFit/>
-          </a:bodyPr>
-          <a:lstStyle/>
-          <a:p>
-            <a:pPr>
-              <a:spcAft>
-                <a:spcPts val="200"/>
-              </a:spcAft>
-            </a:pPr>
-            <a:r>
-              <a:rPr sz="1200" b="0">
-                <a:solidFill>
-                  <a:srgbClr val="5B6676"/>
-                </a:solidFill>
-                <a:latin typeface="Calibri"/>
-              </a:rPr>
-              <a:t>Contacto: Jorge Juri — Project Manager · WhatsApp +1 778 835 3720 · Sigma Digital Twins</a:t>
-            </a:r>
-          </a:p>
-        </p:txBody>
-      </p:sp>
-    </p:spTree>
-  </p:cSld>
-  <p:clrMapOvr>
-    <a:masterClrMapping/>
-  </p:clrMapOvr>
-</p:sld>
-</file>
-
 <file path=ppt/slides/slide2.xml><?xml version="1.0" encoding="utf-8"?>
 <p:sld xmlns:a="http://schemas.openxmlformats.org/drawingml/2006/main" xmlns:p="http://schemas.openxmlformats.org/presentationml/2006/main" xmlns:r="http://schemas.openxmlformats.org/officeDocument/2006/relationships">
   <p:cSld>
@@ -3655,7 +3544,7 @@
         </p:nvSpPr>
         <p:spPr>
           <a:xfrm>
-            <a:off x="4267047" y="777240"/>
+            <a:off x="4267048" y="777240"/>
             <a:ext cx="3657600" cy="566928"/>
           </a:xfrm>
           <a:prstGeom prst="roundRect">
@@ -3732,8 +3621,8 @@
         </p:nvCxnSpPr>
         <p:spPr>
           <a:xfrm>
-            <a:off x="6095847.5" y="1344168"/>
-            <a:ext cx="0.0" cy="137160"/>
+            <a:off x="6095848" y="1344168"/>
+            <a:ext cx="0" cy="137160"/>
           </a:xfrm>
           <a:prstGeom prst="line">
             <a:avLst/>
@@ -3767,7 +3656,7 @@
         </p:nvSpPr>
         <p:spPr>
           <a:xfrm>
-            <a:off x="4267047" y="1481328"/>
+            <a:off x="4267048" y="1481328"/>
             <a:ext cx="3657600" cy="685800"/>
           </a:xfrm>
           <a:prstGeom prst="roundRect">
@@ -3844,8 +3733,8 @@
         </p:nvCxnSpPr>
         <p:spPr>
           <a:xfrm>
-            <a:off x="6095847.5" y="2167128"/>
-            <a:ext cx="0.0" cy="228600"/>
+            <a:off x="6095848" y="2167128"/>
+            <a:ext cx="0" cy="228600"/>
           </a:xfrm>
           <a:prstGeom prst="line">
             <a:avLst/>
@@ -3879,8 +3768,8 @@
         </p:nvCxnSpPr>
         <p:spPr>
           <a:xfrm>
-            <a:off x="2163927.5" y="2395728"/>
-            <a:ext cx="7863840.0" cy="0"/>
+            <a:off x="2163928" y="2395728"/>
+            <a:ext cx="7863840" cy="0"/>
           </a:xfrm>
           <a:prstGeom prst="line">
             <a:avLst/>
@@ -3914,8 +3803,8 @@
         </p:nvCxnSpPr>
         <p:spPr>
           <a:xfrm>
-            <a:off x="2163927.5" y="2395728"/>
-            <a:ext cx="0.0" cy="182880"/>
+            <a:off x="2163928" y="2395728"/>
+            <a:ext cx="0" cy="182880"/>
           </a:xfrm>
           <a:prstGeom prst="line">
             <a:avLst/>
@@ -3949,8 +3838,8 @@
         </p:nvCxnSpPr>
         <p:spPr>
           <a:xfrm>
-            <a:off x="6095847.5" y="2395728"/>
-            <a:ext cx="0.0" cy="182880"/>
+            <a:off x="6095848" y="2395728"/>
+            <a:ext cx="0" cy="182880"/>
           </a:xfrm>
           <a:prstGeom prst="line">
             <a:avLst/>
@@ -3984,8 +3873,8 @@
         </p:nvCxnSpPr>
         <p:spPr>
           <a:xfrm>
-            <a:off x="10027767.5" y="2395728"/>
-            <a:ext cx="0.0" cy="182880"/>
+            <a:off x="10027768" y="2395728"/>
+            <a:ext cx="0" cy="182880"/>
           </a:xfrm>
           <a:prstGeom prst="line">
             <a:avLst/>
@@ -4019,7 +3908,7 @@
         </p:nvSpPr>
         <p:spPr>
           <a:xfrm>
-            <a:off x="357987" y="2578608"/>
+            <a:off x="357988" y="2578608"/>
             <a:ext cx="3611880" cy="868680"/>
           </a:xfrm>
           <a:prstGeom prst="roundRect">
@@ -4096,7 +3985,7 @@
         </p:nvSpPr>
         <p:spPr>
           <a:xfrm>
-            <a:off x="437987" y="2718608"/>
+            <a:off x="437988" y="2718608"/>
             <a:ext cx="70000" cy="588680"/>
           </a:xfrm>
           <a:prstGeom prst="roundRect">
@@ -4142,7 +4031,7 @@
         </p:nvSpPr>
         <p:spPr>
           <a:xfrm>
-            <a:off x="4289907" y="2578608"/>
+            <a:off x="4289908" y="2578608"/>
             <a:ext cx="3611880" cy="868680"/>
           </a:xfrm>
           <a:prstGeom prst="roundRect">
@@ -4219,7 +4108,7 @@
         </p:nvSpPr>
         <p:spPr>
           <a:xfrm>
-            <a:off x="4369907" y="2718608"/>
+            <a:off x="4369908" y="2718608"/>
             <a:ext cx="70000" cy="588680"/>
           </a:xfrm>
           <a:prstGeom prst="roundRect">
@@ -4265,7 +4154,7 @@
         </p:nvSpPr>
         <p:spPr>
           <a:xfrm>
-            <a:off x="8221827" y="2578608"/>
+            <a:off x="8221828" y="2578608"/>
             <a:ext cx="3611880" cy="868680"/>
           </a:xfrm>
           <a:prstGeom prst="roundRect">
@@ -4342,7 +4231,7 @@
         </p:nvSpPr>
         <p:spPr>
           <a:xfrm>
-            <a:off x="8301827" y="2718608"/>
+            <a:off x="8301828" y="2718608"/>
             <a:ext cx="70000" cy="588680"/>
           </a:xfrm>
           <a:prstGeom prst="roundRect">
@@ -4388,8 +4277,8 @@
         </p:nvCxnSpPr>
         <p:spPr>
           <a:xfrm>
-            <a:off x="2163927.5" y="3447288"/>
-            <a:ext cx="0.0" cy="466344"/>
+            <a:off x="2163928" y="3447288"/>
+            <a:ext cx="0" cy="466344"/>
           </a:xfrm>
           <a:prstGeom prst="line">
             <a:avLst/>
@@ -4423,8 +4312,8 @@
         </p:nvCxnSpPr>
         <p:spPr>
           <a:xfrm>
-            <a:off x="1596999.5" y="3913632"/>
-            <a:ext cx="566928.0" cy="0"/>
+            <a:off x="1597000" y="3913632"/>
+            <a:ext cx="566928" cy="0"/>
           </a:xfrm>
           <a:prstGeom prst="line">
             <a:avLst/>
@@ -4458,8 +4347,8 @@
         </p:nvCxnSpPr>
         <p:spPr>
           <a:xfrm>
-            <a:off x="1596999.5" y="3913632"/>
-            <a:ext cx="0.0" cy="246888"/>
+            <a:off x="1597000" y="3913632"/>
+            <a:ext cx="0" cy="246888"/>
           </a:xfrm>
           <a:prstGeom prst="line">
             <a:avLst/>
@@ -4493,8 +4382,8 @@
         </p:nvCxnSpPr>
         <p:spPr>
           <a:xfrm>
-            <a:off x="6095847.5" y="3447288"/>
-            <a:ext cx="0.0" cy="466344"/>
+            <a:off x="6095848" y="3447288"/>
+            <a:ext cx="0" cy="466344"/>
           </a:xfrm>
           <a:prstGeom prst="line">
             <a:avLst/>
@@ -4528,8 +4417,8 @@
         </p:nvCxnSpPr>
         <p:spPr>
           <a:xfrm>
-            <a:off x="4596231.5" y="3913632"/>
-            <a:ext cx="2999232.0" cy="0"/>
+            <a:off x="4596232" y="3913632"/>
+            <a:ext cx="2999232" cy="0"/>
           </a:xfrm>
           <a:prstGeom prst="line">
             <a:avLst/>
@@ -4563,8 +4452,8 @@
         </p:nvCxnSpPr>
         <p:spPr>
           <a:xfrm>
-            <a:off x="4596231.5" y="3913632"/>
-            <a:ext cx="0.0" cy="246888"/>
+            <a:off x="4596232" y="3913632"/>
+            <a:ext cx="0" cy="246888"/>
           </a:xfrm>
           <a:prstGeom prst="line">
             <a:avLst/>
@@ -4598,8 +4487,8 @@
         </p:nvCxnSpPr>
         <p:spPr>
           <a:xfrm>
-            <a:off x="7595463.5" y="3913632"/>
-            <a:ext cx="0.0" cy="246888"/>
+            <a:off x="7595464" y="3913632"/>
+            <a:ext cx="0" cy="246888"/>
           </a:xfrm>
           <a:prstGeom prst="line">
             <a:avLst/>
@@ -4633,8 +4522,8 @@
         </p:nvCxnSpPr>
         <p:spPr>
           <a:xfrm>
-            <a:off x="10027767.5" y="3447288"/>
-            <a:ext cx="0.0" cy="466344"/>
+            <a:off x="10027768" y="3447288"/>
+            <a:ext cx="0" cy="466344"/>
           </a:xfrm>
           <a:prstGeom prst="line">
             <a:avLst/>
@@ -4668,8 +4557,8 @@
         </p:nvCxnSpPr>
         <p:spPr>
           <a:xfrm>
-            <a:off x="10027767.5" y="3913632"/>
-            <a:ext cx="566928.0" cy="0"/>
+            <a:off x="10027768" y="3913632"/>
+            <a:ext cx="566928" cy="0"/>
           </a:xfrm>
           <a:prstGeom prst="line">
             <a:avLst/>
@@ -4703,8 +4592,8 @@
         </p:nvCxnSpPr>
         <p:spPr>
           <a:xfrm>
-            <a:off x="10594695.5" y="3913632"/>
-            <a:ext cx="0.0" cy="246888"/>
+            <a:off x="10594696" y="3913632"/>
+            <a:ext cx="0" cy="246888"/>
           </a:xfrm>
           <a:prstGeom prst="line">
             <a:avLst/>
@@ -4738,7 +4627,7 @@
         </p:nvSpPr>
         <p:spPr>
           <a:xfrm>
-            <a:off x="225399" y="4160520"/>
+            <a:off x="225400" y="4160520"/>
             <a:ext cx="2743200" cy="1051560"/>
           </a:xfrm>
           <a:prstGeom prst="roundRect">
@@ -4815,7 +4704,7 @@
         </p:nvSpPr>
         <p:spPr>
           <a:xfrm>
-            <a:off x="305399" y="4300520"/>
+            <a:off x="305400" y="4300520"/>
             <a:ext cx="70000" cy="771560"/>
           </a:xfrm>
           <a:prstGeom prst="roundRect">
@@ -4861,7 +4750,7 @@
         </p:nvSpPr>
         <p:spPr>
           <a:xfrm>
-            <a:off x="3224631" y="4160520"/>
+            <a:off x="3224632" y="4160520"/>
             <a:ext cx="2743200" cy="1051560"/>
           </a:xfrm>
           <a:prstGeom prst="roundRect">
@@ -4938,7 +4827,7 @@
         </p:nvSpPr>
         <p:spPr>
           <a:xfrm>
-            <a:off x="3304631" y="4300520"/>
+            <a:off x="3304632" y="4300520"/>
             <a:ext cx="70000" cy="771560"/>
           </a:xfrm>
           <a:prstGeom prst="roundRect">
@@ -4984,7 +4873,7 @@
         </p:nvSpPr>
         <p:spPr>
           <a:xfrm>
-            <a:off x="6223863" y="4160520"/>
+            <a:off x="6223864" y="4160520"/>
             <a:ext cx="2743200" cy="1051560"/>
           </a:xfrm>
           <a:prstGeom prst="roundRect">
@@ -5061,7 +4950,7 @@
         </p:nvSpPr>
         <p:spPr>
           <a:xfrm>
-            <a:off x="6303863" y="4300520"/>
+            <a:off x="6303864" y="4300520"/>
             <a:ext cx="70000" cy="771560"/>
           </a:xfrm>
           <a:prstGeom prst="roundRect">
@@ -5107,7 +4996,7 @@
         </p:nvSpPr>
         <p:spPr>
           <a:xfrm>
-            <a:off x="9223095" y="4160520"/>
+            <a:off x="9223096" y="4160520"/>
             <a:ext cx="2743200" cy="1051560"/>
           </a:xfrm>
           <a:prstGeom prst="roundRect">
@@ -5184,7 +5073,7 @@
         </p:nvSpPr>
         <p:spPr>
           <a:xfrm>
-            <a:off x="9303095" y="4300520"/>
+            <a:off x="9303096" y="4300520"/>
             <a:ext cx="70000" cy="771560"/>
           </a:xfrm>
           <a:prstGeom prst="roundRect">
@@ -5230,7 +5119,7 @@
         </p:nvSpPr>
         <p:spPr>
           <a:xfrm>
-            <a:off x="225399" y="5623560"/>
+            <a:off x="225400" y="5623560"/>
             <a:ext cx="11740896" cy="502920"/>
           </a:xfrm>
           <a:prstGeom prst="roundRect">

</xml_diff>